<commit_message>
rate limit checking convenience script
Signed-off-by: Sean P. Goggins <s@goggins.com>
</commit_message>
<xml_diff>
--- a/aveloxis-story/aveloxis-presentation.pptx
+++ b/aveloxis-story/aveloxis-presentation.pptx
@@ -5111,7 +5111,7 @@
         </p:nvSpPr>
         <p:spPr>
           <a:xfrm>
-            <a:off x="548640" y="320040"/>
+            <a:off x="548640" y="453852"/>
             <a:ext cx="8229600" cy="548640"/>
           </a:xfrm>
           <a:prstGeom prst="rect">
@@ -5150,7 +5150,7 @@
         </p:nvSpPr>
         <p:spPr>
           <a:xfrm>
-            <a:off x="548640" y="822960"/>
+            <a:off x="548640" y="914400"/>
             <a:ext cx="5486400" cy="274320"/>
           </a:xfrm>
           <a:prstGeom prst="rect">
@@ -5190,7 +5190,7 @@
         <p:spPr>
           <a:xfrm>
             <a:off x="548640" y="1280160"/>
-            <a:ext cx="3840480" cy="3017520"/>
+            <a:ext cx="3108960" cy="2377440"/>
           </a:xfrm>
           <a:prstGeom prst="rect">
             <a:avLst/>
@@ -5389,8 +5389,8 @@
         </p:nvSpPr>
         <p:spPr>
           <a:xfrm>
-            <a:off x="4754880" y="1280160"/>
-            <a:ext cx="3840480" cy="3017520"/>
+            <a:off x="3931920" y="1280160"/>
+            <a:ext cx="3291840" cy="2377440"/>
           </a:xfrm>
           <a:prstGeom prst="rect">
             <a:avLst/>
@@ -5423,7 +5423,7 @@
         </p:nvSpPr>
         <p:spPr>
           <a:xfrm>
-            <a:off x="5029200" y="1417320"/>
+            <a:off x="4183380" y="1417320"/>
             <a:ext cx="3291840" cy="365760"/>
           </a:xfrm>
           <a:prstGeom prst="rect">
@@ -5462,7 +5462,7 @@
         </p:nvSpPr>
         <p:spPr>
           <a:xfrm>
-            <a:off x="5029200" y="1920240"/>
+            <a:off x="4183380" y="1920240"/>
             <a:ext cx="3291840" cy="2194560"/>
           </a:xfrm>
           <a:prstGeom prst="rect">
@@ -5610,8 +5610,8 @@
         </p:nvSpPr>
         <p:spPr>
           <a:xfrm>
-            <a:off x="548640" y="4572000"/>
-            <a:ext cx="8229600" cy="365760"/>
+            <a:off x="502920" y="3657600"/>
+            <a:ext cx="7223760" cy="365760"/>
           </a:xfrm>
           <a:prstGeom prst="rect">
             <a:avLst/>
@@ -5635,7 +5635,23 @@
                 <a:ea typeface="Calibri" pitchFamily="34" charset="-122"/>
                 <a:cs typeface="Calibri" pitchFamily="34" charset="-120"/>
               </a:rPr>
-              <a:t>Key fix: Scheduler changed from one-job-per-tick to greedy fill-all-slots — 40 workers filled in seconds instead of 400s</a:t>
+              <a:t>Key fix: Scheduler changed from one-job-per-tick to greedy fill-all-slots — </a:t>
+            </a:r>
+          </a:p>
+          <a:p>
+            <a:pPr marL="0" indent="0" algn="ctr">
+              <a:buNone/>
+            </a:pPr>
+            <a:r>
+              <a:rPr lang="en-US" sz="1200" i="1" dirty="0">
+                <a:solidFill>
+                  <a:srgbClr val="F59E0B"/>
+                </a:solidFill>
+                <a:latin typeface="Calibri" pitchFamily="34" charset="0"/>
+                <a:ea typeface="Calibri" pitchFamily="34" charset="-122"/>
+                <a:cs typeface="Calibri" pitchFamily="34" charset="-120"/>
+              </a:rPr>
+              <a:t>40 workers filled in seconds instead of 400s</a:t>
             </a:r>
             <a:endParaRPr lang="en-US" sz="1200" dirty="0"/>
           </a:p>
@@ -5760,8 +5776,8 @@
         </p:nvSpPr>
         <p:spPr>
           <a:xfrm>
-            <a:off x="548640" y="1280160"/>
-            <a:ext cx="3840480" cy="3017520"/>
+            <a:off x="548640" y="1072004"/>
+            <a:ext cx="3840480" cy="2072640"/>
           </a:xfrm>
           <a:prstGeom prst="rect">
             <a:avLst/>
@@ -5794,7 +5810,7 @@
         </p:nvSpPr>
         <p:spPr>
           <a:xfrm>
-            <a:off x="822960" y="1417320"/>
+            <a:off x="822960" y="1209164"/>
             <a:ext cx="3291840" cy="365760"/>
           </a:xfrm>
           <a:prstGeom prst="rect">
@@ -5833,7 +5849,7 @@
         </p:nvSpPr>
         <p:spPr>
           <a:xfrm>
-            <a:off x="822960" y="1920240"/>
+            <a:off x="822960" y="1712084"/>
             <a:ext cx="3291840" cy="2194560"/>
           </a:xfrm>
           <a:prstGeom prst="rect">
@@ -5960,8 +5976,8 @@
         </p:nvSpPr>
         <p:spPr>
           <a:xfrm>
-            <a:off x="4754880" y="1280160"/>
-            <a:ext cx="3840480" cy="3017520"/>
+            <a:off x="4754880" y="1072004"/>
+            <a:ext cx="3840480" cy="2072640"/>
           </a:xfrm>
           <a:prstGeom prst="rect">
             <a:avLst/>
@@ -5994,7 +6010,7 @@
         </p:nvSpPr>
         <p:spPr>
           <a:xfrm>
-            <a:off x="5029200" y="1417320"/>
+            <a:off x="5029200" y="1209164"/>
             <a:ext cx="3291840" cy="365760"/>
           </a:xfrm>
           <a:prstGeom prst="rect">
@@ -6033,7 +6049,7 @@
         </p:nvSpPr>
         <p:spPr>
           <a:xfrm>
-            <a:off x="5029200" y="1920240"/>
+            <a:off x="5029200" y="1712084"/>
             <a:ext cx="3291840" cy="2194560"/>
           </a:xfrm>
           <a:prstGeom prst="rect">
@@ -6160,7 +6176,7 @@
         </p:nvSpPr>
         <p:spPr>
           <a:xfrm>
-            <a:off x="548640" y="4572000"/>
+            <a:off x="457200" y="3159884"/>
             <a:ext cx="8229600" cy="365760"/>
           </a:xfrm>
           <a:prstGeom prst="rect">
@@ -6232,7 +6248,7 @@
         </p:nvSpPr>
         <p:spPr>
           <a:xfrm>
-            <a:off x="548639" y="320040"/>
+            <a:off x="548640" y="502920"/>
             <a:ext cx="7740433" cy="548640"/>
           </a:xfrm>
           <a:prstGeom prst="rect">
@@ -6271,7 +6287,7 @@
         </p:nvSpPr>
         <p:spPr>
           <a:xfrm>
-            <a:off x="548640" y="1060704"/>
+            <a:off x="585216" y="1010895"/>
             <a:ext cx="4572000" cy="274320"/>
           </a:xfrm>
           <a:prstGeom prst="rect">
@@ -6410,7 +6426,7 @@
         </p:nvSpPr>
         <p:spPr>
           <a:xfrm>
-            <a:off x="868680" y="1627632"/>
+            <a:off x="868680" y="1545336"/>
             <a:ext cx="7498080" cy="347472"/>
           </a:xfrm>
           <a:prstGeom prst="rect">
@@ -6435,7 +6451,29 @@
                 <a:ea typeface="Calibri" pitchFamily="34" charset="-122"/>
                 <a:cs typeface="Calibri" pitchFamily="34" charset="-120"/>
               </a:rPr>
-              <a:t>RecoverStaleLocks was stealing active jobs hourly on large repos, destroying staging data. Fixed: 30s heartbeats.</a:t>
+              <a:t>RecoverStaleLocks was stealing active jobs hourly on large repos, destroying staging data. Fixed: 30s heartbeats. I noticed this issue during load testing. Because I knew everything that can go wrong, I also knew what to look for in </a:t>
+            </a:r>
+            <a:r>
+              <a:rPr lang="en-US" sz="1200" dirty="0" err="1">
+                <a:solidFill>
+                  <a:srgbClr val="94A3B8"/>
+                </a:solidFill>
+                <a:latin typeface="Calibri" pitchFamily="34" charset="0"/>
+                <a:ea typeface="Calibri" pitchFamily="34" charset="-122"/>
+                <a:cs typeface="Calibri" pitchFamily="34" charset="-120"/>
+              </a:rPr>
+              <a:t>Aveloxis</a:t>
+            </a:r>
+            <a:r>
+              <a:rPr lang="en-US" sz="1200" dirty="0">
+                <a:solidFill>
+                  <a:srgbClr val="94A3B8"/>
+                </a:solidFill>
+                <a:latin typeface="Calibri" pitchFamily="34" charset="0"/>
+                <a:ea typeface="Calibri" pitchFamily="34" charset="-122"/>
+                <a:cs typeface="Calibri" pitchFamily="34" charset="-120"/>
+              </a:rPr>
+              <a:t>.</a:t>
             </a:r>
             <a:endParaRPr lang="en-US" sz="1200" dirty="0"/>
           </a:p>
@@ -6574,7 +6612,7 @@
                 <a:ea typeface="Calibri" pitchFamily="34" charset="-122"/>
                 <a:cs typeface="Calibri" pitchFamily="34" charset="-120"/>
               </a:rPr>
-              <a:t>ON CONFLICT ON CONSTRAINT (invalid PG) caused 131K messages to lose contributor attribution. Silent for entire lifetime.</a:t>
+              <a:t>ON CONFLICT ON CONSTRAINT (invalid PG) caused 131K messages to lose contributor attribution. Silent for entire lifetime. Identified and fixed this issue. </a:t>
             </a:r>
             <a:endParaRPr lang="en-US" sz="1200" dirty="0"/>
           </a:p>
@@ -6713,7 +6751,7 @@
                 <a:ea typeface="Calibri" pitchFamily="34" charset="-122"/>
                 <a:cs typeface="Calibri" pitchFamily="34" charset="-120"/>
               </a:rPr>
-              <a:t>All 13K+ contributors had empty profiles. Added EnrichThinContributors phase (GET /users/{login}).</a:t>
+              <a:t>All 13K+ contributors had empty profiles. Added EnrichThinContributors phase (GET /users/{login}). Identified and fixed this issue</a:t>
             </a:r>
             <a:endParaRPr lang="en-US" sz="1200" dirty="0"/>
           </a:p>
@@ -6852,7 +6890,7 @@
                 <a:ea typeface="Calibri" pitchFamily="34" charset="-122"/>
                 <a:cs typeface="Calibri" pitchFamily="34" charset="-120"/>
               </a:rPr>
-              <a:t>Lists all issue/PR numbers from API, diffs against DB, fetches only missing items + 2 edge items per gap.</a:t>
+              <a:t>Lists all issue/PR numbers from API, diffs against DB, fetches only missing items + 2 edge items per gap. A smarter strategy for filling in missed data. </a:t>
             </a:r>
             <a:endParaRPr lang="en-US" sz="1200" dirty="0"/>
           </a:p>
@@ -6866,7 +6904,7 @@
         </p:nvSpPr>
         <p:spPr>
           <a:xfrm>
-            <a:off x="548640" y="4709160"/>
+            <a:off x="502920" y="4617720"/>
             <a:ext cx="8229600" cy="274320"/>
           </a:xfrm>
           <a:prstGeom prst="rect">
@@ -8117,7 +8155,7 @@
         </p:nvSpPr>
         <p:spPr>
           <a:xfrm>
-            <a:off x="548640" y="320040"/>
+            <a:off x="548640" y="411480"/>
             <a:ext cx="8229600" cy="548640"/>
           </a:xfrm>
           <a:prstGeom prst="rect">
@@ -8392,7 +8430,7 @@
                 <a:ea typeface="Trebuchet MS" pitchFamily="34" charset="-122"/>
                 <a:cs typeface="Trebuchet MS" pitchFamily="34" charset="-120"/>
               </a:rPr>
-              <a:t>200+</a:t>
+              <a:t>600+</a:t>
             </a:r>
             <a:endParaRPr lang="en-US" sz="2800" dirty="0"/>
           </a:p>
@@ -8698,7 +8736,7 @@
                 <a:ea typeface="Trebuchet MS" pitchFamily="34" charset="-122"/>
                 <a:cs typeface="Trebuchet MS" pitchFamily="34" charset="-120"/>
               </a:rPr>
-              <a:t>19</a:t>
+              <a:t>22</a:t>
             </a:r>
             <a:endParaRPr lang="en-US" sz="2800" dirty="0"/>
           </a:p>
@@ -9043,7 +9081,7 @@
                 <a:ea typeface="Calibri" pitchFamily="34" charset="-122"/>
                 <a:cs typeface="Calibri" pitchFamily="34" charset="-120"/>
               </a:rPr>
-              <a:t>Production Repos</a:t>
+              <a:t>FULL TEST: Production Repos</a:t>
             </a:r>
             <a:endParaRPr lang="en-US" sz="1100" dirty="0"/>
           </a:p>

</xml_diff>